<commit_message>
A7 Unit 6: lesson 6.03 (GR.1.1) at 0 findings — the square corner first (Notes I and board 5 turned), the hypotenuse by adding squares, a leg by subtracting and checking it is shorter than c; every irrational answer exact and to the tenth, every radicand whole ≤ 225 and square-free; board 2's double-rounding trap is the book's own 6.04 key error, named. figs.slide sizes a figure by drawing it
Co-Authored-By: Claude Opus 5.5 <noreply@anthropic.com>
Claude-Session: https://claude.ai/code/session_018Be467MLKJu6DjkSsjpM7D
</commit_message>
<xml_diff>
--- a/a7/build/out/u6/A7 6.01 Triangle Inequality Theorem; Converse of the Pythagorean Theorem - Slides.pptx
+++ b/a7/build/out/u6/A7 6.01 Triangle Inequality Theorem; Converse of the Pythagorean Theorem - Slides.pptx
@@ -16935,7 +16935,7 @@
       </p:cxnSp>
       <p:pic>
         <p:nvPicPr>
-          <p:cNvPr id="10" name="Picture 9" descr="g81554dfe2734142e.png"/>
+          <p:cNvPr id="10" name="Picture 9" descr="g6d978ce3bc7c14d0.png"/>
           <p:cNvPicPr>
             <a:picLocks noChangeAspect="1"/>
           </p:cNvPicPr>
@@ -16949,8 +16949,8 @@
         </p:blipFill>
         <p:spPr>
           <a:xfrm>
-            <a:off x="4914900" y="1993392"/>
-            <a:ext cx="2331720" cy="2134610"/>
+            <a:off x="5006340" y="1993392"/>
+            <a:ext cx="2148840" cy="1967189"/>
           </a:xfrm>
           <a:prstGeom prst="rect">
             <a:avLst/>
@@ -16973,7 +16973,7 @@
         </p:blipFill>
         <p:spPr>
           <a:xfrm>
-            <a:off x="4081271" y="4274306"/>
+            <a:off x="4081271" y="4106885"/>
             <a:ext cx="3998975" cy="341376"/>
           </a:xfrm>
           <a:prstGeom prst="rect">
@@ -16989,7 +16989,7 @@
         </p:nvSpPr>
         <p:spPr>
           <a:xfrm>
-            <a:off x="987552" y="5024114"/>
+            <a:off x="987552" y="4856693"/>
             <a:ext cx="10131551" cy="475488"/>
           </a:xfrm>
           <a:prstGeom prst="rect">
@@ -17032,7 +17032,7 @@
         </p:blipFill>
         <p:spPr>
           <a:xfrm>
-            <a:off x="987552" y="5834278"/>
+            <a:off x="987552" y="5666858"/>
             <a:ext cx="1056124" cy="272930"/>
           </a:xfrm>
           <a:prstGeom prst="rect">
@@ -17048,7 +17048,7 @@
         </p:nvSpPr>
         <p:spPr>
           <a:xfrm>
-            <a:off x="2043676" y="5714486"/>
+            <a:off x="2043676" y="5547065"/>
             <a:ext cx="442110" cy="457200"/>
           </a:xfrm>
           <a:prstGeom prst="rect">
@@ -17091,7 +17091,7 @@
         </p:blipFill>
         <p:spPr>
           <a:xfrm>
-            <a:off x="2348626" y="5789185"/>
+            <a:off x="2348626" y="5621765"/>
             <a:ext cx="2506218" cy="265811"/>
           </a:xfrm>
           <a:prstGeom prst="rect">
@@ -17107,7 +17107,7 @@
         </p:nvSpPr>
         <p:spPr>
           <a:xfrm>
-            <a:off x="4854844" y="5714486"/>
+            <a:off x="4854844" y="5547065"/>
             <a:ext cx="1446938" cy="457200"/>
           </a:xfrm>
           <a:prstGeom prst="rect">
@@ -17150,7 +17150,7 @@
         </p:blipFill>
         <p:spPr>
           <a:xfrm>
-            <a:off x="6164623" y="5834278"/>
+            <a:off x="6164623" y="5666858"/>
             <a:ext cx="757086" cy="272930"/>
           </a:xfrm>
           <a:prstGeom prst="rect">
@@ -17166,7 +17166,7 @@
         </p:nvSpPr>
         <p:spPr>
           <a:xfrm>
-            <a:off x="6921710" y="5714486"/>
+            <a:off x="6921710" y="5547065"/>
             <a:ext cx="442110" cy="457200"/>
           </a:xfrm>
           <a:prstGeom prst="rect">
@@ -17209,7 +17209,7 @@
         </p:blipFill>
         <p:spPr>
           <a:xfrm>
-            <a:off x="7226661" y="5789185"/>
+            <a:off x="7226661" y="5621765"/>
             <a:ext cx="1450093" cy="265811"/>
           </a:xfrm>
           <a:prstGeom prst="rect">
@@ -17225,7 +17225,7 @@
         </p:nvSpPr>
         <p:spPr>
           <a:xfrm>
-            <a:off x="8676754" y="5714486"/>
+            <a:off x="8676754" y="5547065"/>
             <a:ext cx="922443" cy="457200"/>
           </a:xfrm>
           <a:prstGeom prst="rect">
@@ -17268,7 +17268,7 @@
         </p:blipFill>
         <p:spPr>
           <a:xfrm>
-            <a:off x="9462038" y="5836652"/>
+            <a:off x="9462038" y="5669231"/>
             <a:ext cx="332263" cy="215971"/>
           </a:xfrm>
           <a:prstGeom prst="rect">
@@ -17284,7 +17284,7 @@
         </p:nvSpPr>
         <p:spPr>
           <a:xfrm>
-            <a:off x="9794302" y="5714486"/>
+            <a:off x="9794302" y="5547065"/>
             <a:ext cx="277353" cy="457200"/>
           </a:xfrm>
           <a:prstGeom prst="rect">

</xml_diff>